<commit_message>
Simplify slide_deck.pptx for a non-technical audience
Drop the tech-stack chip row and the ticker/filing demo line;
keep the headline 20-30 min -> <60 sec metric front and center.

Co-Authored-By: Claude Sonnet 5 <noreply@anthropic.com>
</commit_message>
<xml_diff>
--- a/slide/slide_deck.pptx
+++ b/slide/slide_deck.pptx
@@ -3720,31 +3720,6 @@
               <a:t>PER-TICKER PREP TIME, ONE AGENT RUN</a:t>
             </a:r>
           </a:p>
-          <a:p>
-            <a:pPr>
-              <a:spcBef>
-                <a:spcPts val="1000"/>
-              </a:spcBef>
-            </a:pPr>
-            <a:r>
-              <a:rPr sz="1100" b="0" i="0">
-                <a:solidFill>
-                  <a:srgbClr val="4F8F6D"/>
-                </a:solidFill>
-                <a:latin typeface="Consolas"/>
-              </a:rPr>
-              <a:t>●  </a:t>
-            </a:r>
-            <a:r>
-              <a:rPr sz="1100" b="0" i="0">
-                <a:solidFill>
-                  <a:srgbClr val="4F8F6D"/>
-                </a:solidFill>
-                <a:latin typeface="Consolas"/>
-              </a:rPr>
-              <a:t>AAPL · quote fetched · 10-Q read · briefing ready</a:t>
-            </a:r>
-          </a:p>
         </p:txBody>
       </p:sp>
       <p:sp>
@@ -3793,289 +3768,14 @@
       </p:sp>
       <p:sp>
         <p:nvSpPr>
-          <p:cNvPr id="15" name="Rounded Rectangle 14"/>
-          <p:cNvSpPr/>
+          <p:cNvPr id="15" name="TextBox 14"/>
+          <p:cNvSpPr txBox="1"/>
           <p:nvPr/>
         </p:nvSpPr>
         <p:spPr>
           <a:xfrm>
-            <a:off x="502920" y="6153912"/>
-            <a:ext cx="1609344" cy="329184"/>
-          </a:xfrm>
-          <a:prstGeom prst="roundRect">
-            <a:avLst>
-              <a:gd name="adj" fmla="val 50000"/>
-            </a:avLst>
-          </a:prstGeom>
-          <a:noFill/>
-          <a:ln w="9525">
-            <a:solidFill>
-              <a:srgbClr val="2A3B52"/>
-            </a:solidFill>
-          </a:ln>
-          <a:effectLst/>
-        </p:spPr>
-        <p:style>
-          <a:lnRef idx="1">
-            <a:schemeClr val="accent1"/>
-          </a:lnRef>
-          <a:fillRef idx="3">
-            <a:schemeClr val="accent1"/>
-          </a:fillRef>
-          <a:effectRef idx="2">
-            <a:schemeClr val="accent1"/>
-          </a:effectRef>
-          <a:fontRef idx="minor">
-            <a:schemeClr val="lt1"/>
-          </a:fontRef>
-        </p:style>
-        <p:txBody>
-          <a:bodyPr rtlCol="0" anchor="ctr" wrap="none" lIns="73152" rIns="73152" tIns="18288" bIns="18288"/>
-          <a:lstStyle/>
-          <a:p>
-            <a:pPr algn="ctr"/>
-            <a:r>
-              <a:rPr sz="950" b="0" i="0">
-                <a:solidFill>
-                  <a:srgbClr val="D9D2C1"/>
-                </a:solidFill>
-                <a:latin typeface="Consolas"/>
-              </a:rPr>
-              <a:t>Next.js / Vercel</a:t>
-            </a:r>
-          </a:p>
-        </p:txBody>
-      </p:sp>
-      <p:sp>
-        <p:nvSpPr>
-          <p:cNvPr id="16" name="Rounded Rectangle 15"/>
-          <p:cNvSpPr/>
-          <p:nvPr/>
-        </p:nvSpPr>
-        <p:spPr>
-          <a:xfrm>
-            <a:off x="2276856" y="6153912"/>
-            <a:ext cx="2112264" cy="329184"/>
-          </a:xfrm>
-          <a:prstGeom prst="roundRect">
-            <a:avLst>
-              <a:gd name="adj" fmla="val 50000"/>
-            </a:avLst>
-          </a:prstGeom>
-          <a:noFill/>
-          <a:ln w="9525">
-            <a:solidFill>
-              <a:srgbClr val="2A3B52"/>
-            </a:solidFill>
-          </a:ln>
-          <a:effectLst/>
-        </p:spPr>
-        <p:style>
-          <a:lnRef idx="1">
-            <a:schemeClr val="accent1"/>
-          </a:lnRef>
-          <a:fillRef idx="3">
-            <a:schemeClr val="accent1"/>
-          </a:fillRef>
-          <a:effectRef idx="2">
-            <a:schemeClr val="accent1"/>
-          </a:effectRef>
-          <a:fontRef idx="minor">
-            <a:schemeClr val="lt1"/>
-          </a:fontRef>
-        </p:style>
-        <p:txBody>
-          <a:bodyPr rtlCol="0" anchor="ctr" wrap="none" lIns="73152" rIns="73152" tIns="18288" bIns="18288"/>
-          <a:lstStyle/>
-          <a:p>
-            <a:pPr algn="ctr"/>
-            <a:r>
-              <a:rPr sz="950" b="0" i="0">
-                <a:solidFill>
-                  <a:srgbClr val="D9D2C1"/>
-                </a:solidFill>
-                <a:latin typeface="Consolas"/>
-              </a:rPr>
-              <a:t>Trigger.dev agent run</a:t>
-            </a:r>
-          </a:p>
-        </p:txBody>
-      </p:sp>
-      <p:sp>
-        <p:nvSpPr>
-          <p:cNvPr id="17" name="Rounded Rectangle 16"/>
-          <p:cNvSpPr/>
-          <p:nvPr/>
-        </p:nvSpPr>
-        <p:spPr>
-          <a:xfrm>
-            <a:off x="4553712" y="6153912"/>
-            <a:ext cx="2916936" cy="329184"/>
-          </a:xfrm>
-          <a:prstGeom prst="roundRect">
-            <a:avLst>
-              <a:gd name="adj" fmla="val 50000"/>
-            </a:avLst>
-          </a:prstGeom>
-          <a:noFill/>
-          <a:ln w="9525">
-            <a:solidFill>
-              <a:srgbClr val="2A3B52"/>
-            </a:solidFill>
-          </a:ln>
-          <a:effectLst/>
-        </p:spPr>
-        <p:style>
-          <a:lnRef idx="1">
-            <a:schemeClr val="accent1"/>
-          </a:lnRef>
-          <a:fillRef idx="3">
-            <a:schemeClr val="accent1"/>
-          </a:fillRef>
-          <a:effectRef idx="2">
-            <a:schemeClr val="accent1"/>
-          </a:effectRef>
-          <a:fontRef idx="minor">
-            <a:schemeClr val="lt1"/>
-          </a:fontRef>
-        </p:style>
-        <p:txBody>
-          <a:bodyPr rtlCol="0" anchor="ctr" wrap="none" lIns="73152" rIns="73152" tIns="18288" bIns="18288"/>
-          <a:lstStyle/>
-          <a:p>
-            <a:pPr algn="ctr"/>
-            <a:r>
-              <a:rPr sz="950" b="0" i="0">
-                <a:solidFill>
-                  <a:srgbClr val="D9D2C1"/>
-                </a:solidFill>
-                <a:latin typeface="Consolas"/>
-              </a:rPr>
-              <a:t>Claude Sonnet 4.5 via Portkey</a:t>
-            </a:r>
-          </a:p>
-        </p:txBody>
-      </p:sp>
-      <p:sp>
-        <p:nvSpPr>
-          <p:cNvPr id="18" name="Rounded Rectangle 17"/>
-          <p:cNvSpPr/>
-          <p:nvPr/>
-        </p:nvSpPr>
-        <p:spPr>
-          <a:xfrm>
-            <a:off x="7635240" y="6153912"/>
-            <a:ext cx="1911095" cy="329184"/>
-          </a:xfrm>
-          <a:prstGeom prst="roundRect">
-            <a:avLst>
-              <a:gd name="adj" fmla="val 50000"/>
-            </a:avLst>
-          </a:prstGeom>
-          <a:noFill/>
-          <a:ln w="9525">
-            <a:solidFill>
-              <a:srgbClr val="2A3B52"/>
-            </a:solidFill>
-          </a:ln>
-          <a:effectLst/>
-        </p:spPr>
-        <p:style>
-          <a:lnRef idx="1">
-            <a:schemeClr val="accent1"/>
-          </a:lnRef>
-          <a:fillRef idx="3">
-            <a:schemeClr val="accent1"/>
-          </a:fillRef>
-          <a:effectRef idx="2">
-            <a:schemeClr val="accent1"/>
-          </a:effectRef>
-          <a:fontRef idx="minor">
-            <a:schemeClr val="lt1"/>
-          </a:fontRef>
-        </p:style>
-        <p:txBody>
-          <a:bodyPr rtlCol="0" anchor="ctr" wrap="none" lIns="73152" rIns="73152" tIns="18288" bIns="18288"/>
-          <a:lstStyle/>
-          <a:p>
-            <a:pPr algn="ctr"/>
-            <a:r>
-              <a:rPr sz="950" b="0" i="0">
-                <a:solidFill>
-                  <a:srgbClr val="D9D2C1"/>
-                </a:solidFill>
-                <a:latin typeface="Consolas"/>
-              </a:rPr>
-              <a:t>EDGAR + market data</a:t>
-            </a:r>
-          </a:p>
-        </p:txBody>
-      </p:sp>
-      <p:sp>
-        <p:nvSpPr>
-          <p:cNvPr id="19" name="Rounded Rectangle 18"/>
-          <p:cNvSpPr/>
-          <p:nvPr/>
-        </p:nvSpPr>
-        <p:spPr>
-          <a:xfrm>
-            <a:off x="9710927" y="6153912"/>
-            <a:ext cx="1307592" cy="329184"/>
-          </a:xfrm>
-          <a:prstGeom prst="roundRect">
-            <a:avLst>
-              <a:gd name="adj" fmla="val 50000"/>
-            </a:avLst>
-          </a:prstGeom>
-          <a:noFill/>
-          <a:ln w="9525">
-            <a:solidFill>
-              <a:srgbClr val="2A3B52"/>
-            </a:solidFill>
-          </a:ln>
-          <a:effectLst/>
-        </p:spPr>
-        <p:style>
-          <a:lnRef idx="1">
-            <a:schemeClr val="accent1"/>
-          </a:lnRef>
-          <a:fillRef idx="3">
-            <a:schemeClr val="accent1"/>
-          </a:fillRef>
-          <a:effectRef idx="2">
-            <a:schemeClr val="accent1"/>
-          </a:effectRef>
-          <a:fontRef idx="minor">
-            <a:schemeClr val="lt1"/>
-          </a:fontRef>
-        </p:style>
-        <p:txBody>
-          <a:bodyPr rtlCol="0" anchor="ctr" wrap="none" lIns="73152" rIns="73152" tIns="18288" bIns="18288"/>
-          <a:lstStyle/>
-          <a:p>
-            <a:pPr algn="ctr"/>
-            <a:r>
-              <a:rPr sz="950" b="0" i="0">
-                <a:solidFill>
-                  <a:srgbClr val="D9D2C1"/>
-                </a:solidFill>
-                <a:latin typeface="Consolas"/>
-              </a:rPr>
-              <a:t>Neon Postgres</a:t>
-            </a:r>
-          </a:p>
-        </p:txBody>
-      </p:sp>
-      <p:sp>
-        <p:nvSpPr>
-          <p:cNvPr id="20" name="TextBox 19"/>
-          <p:cNvSpPr txBox="1"/>
-          <p:nvPr/>
-        </p:nvSpPr>
-        <p:spPr>
-          <a:xfrm>
-            <a:off x="8396935" y="6153912"/>
-            <a:ext cx="3291840" cy="640080"/>
+            <a:off x="502920" y="6172200"/>
+            <a:ext cx="11185855" cy="548640"/>
           </a:xfrm>
           <a:prstGeom prst="rect">
             <a:avLst/>
@@ -4088,19 +3788,19 @@
           </a:bodyPr>
           <a:lstStyle/>
           <a:p>
-            <a:pPr algn="r">
+            <a:pPr algn="ctr">
               <a:lnSpc>
                 <a:spcPct val="130000"/>
               </a:lnSpc>
             </a:pPr>
             <a:r>
-              <a:rPr sz="1050" b="0" i="0">
+              <a:rPr sz="1200" b="0" i="0">
                 <a:solidFill>
                   <a:srgbClr val="D9D2C1"/>
                 </a:solidFill>
                 <a:latin typeface="Calibri"/>
               </a:rPr>
-              <a:t>Built to extend: earnings-call transcripts, analyst notes, portfolio-level batch briefings — same agent, more sources.</a:t>
+              <a:t>Built to extend to more research beyond a single ticker — same approach, more coverage.</a:t>
             </a:r>
           </a:p>
         </p:txBody>

</xml_diff>